<commit_message>
Add Studio panel slide to Beyond the Demo deck
</commit_message>
<xml_diff>
--- a/decks/colab_demo.pptx
+++ b/decks/colab_demo.pptx
@@ -2749,7 +2749,7 @@
           </p:nvPr>
         </p:nvGraphicFramePr>
         <p:xfrm>
-          <a:off x="457200" y="1325880"/>
+          <a:off x="457200" y="1280160"/>
           <a:ext cx="8229600" cy="914400"/>
         </p:xfrm>
         <a:graphic>
@@ -2760,7 +2760,7 @@
                 <a:gridCol w="3291840"/>
                 <a:gridCol w="4937760"/>
               </a:tblGrid>
-              <a:tr h="301752">
+              <a:tr h="274320">
                 <a:tc>
                   <a:txBody>
                     <a:bodyPr/>
@@ -2787,7 +2787,7 @@
                       </a:endParaRPr>
                     </a:p>
                   </a:txBody>
-                  <a:tcPr marL="91440" marR="91440" marT="0" marB="0" anchor="ctr">
+                  <a:tcPr marL="73152" marR="73152" marT="0" marB="0" anchor="ctr">
                     <a:lnL w="9525" cap="flat" cmpd="sng" algn="ctr">
                       <a:solidFill>
                         <a:srgbClr val="E2E8F0"/>
@@ -2855,7 +2855,7 @@
                       </a:endParaRPr>
                     </a:p>
                   </a:txBody>
-                  <a:tcPr marL="91440" marR="91440" marT="0" marB="0" anchor="ctr">
+                  <a:tcPr marL="73152" marR="73152" marT="0" marB="0" anchor="ctr">
                     <a:lnL w="9525" cap="flat" cmpd="sng" algn="ctr">
                       <a:solidFill>
                         <a:srgbClr val="E2E8F0"/>
@@ -2898,7 +2898,7 @@
                   </a:tcPr>
                 </a:tc>
               </a:tr>
-              <a:tr h="301752">
+              <a:tr h="274320">
                 <a:tc>
                   <a:txBody>
                     <a:bodyPr/>
@@ -2925,7 +2925,7 @@
                       </a:endParaRPr>
                     </a:p>
                   </a:txBody>
-                  <a:tcPr marL="91440" marR="91440" marT="0" marB="0" anchor="ctr">
+                  <a:tcPr marL="73152" marR="73152" marT="0" marB="0" anchor="ctr">
                     <a:lnL w="9525" cap="flat" cmpd="sng" algn="ctr">
                       <a:solidFill>
                         <a:srgbClr val="E2E8F0"/>
@@ -2993,7 +2993,7 @@
                       </a:endParaRPr>
                     </a:p>
                   </a:txBody>
-                  <a:tcPr marL="91440" marR="91440" marT="0" marB="0" anchor="ctr">
+                  <a:tcPr marL="73152" marR="73152" marT="0" marB="0" anchor="ctr">
                     <a:lnL w="9525" cap="flat" cmpd="sng" algn="ctr">
                       <a:solidFill>
                         <a:srgbClr val="E2E8F0"/>
@@ -3036,7 +3036,7 @@
                   </a:tcPr>
                 </a:tc>
               </a:tr>
-              <a:tr h="301752">
+              <a:tr h="274320">
                 <a:tc>
                   <a:txBody>
                     <a:bodyPr/>
@@ -3063,7 +3063,7 @@
                       </a:endParaRPr>
                     </a:p>
                   </a:txBody>
-                  <a:tcPr marL="91440" marR="91440" marT="0" marB="0" anchor="ctr">
+                  <a:tcPr marL="73152" marR="73152" marT="0" marB="0" anchor="ctr">
                     <a:lnL w="9525" cap="flat" cmpd="sng" algn="ctr">
                       <a:solidFill>
                         <a:srgbClr val="E2E8F0"/>
@@ -3131,7 +3131,7 @@
                       </a:endParaRPr>
                     </a:p>
                   </a:txBody>
-                  <a:tcPr marL="91440" marR="91440" marT="0" marB="0" anchor="ctr">
+                  <a:tcPr marL="73152" marR="73152" marT="0" marB="0" anchor="ctr">
                     <a:lnL w="9525" cap="flat" cmpd="sng" algn="ctr">
                       <a:solidFill>
                         <a:srgbClr val="E2E8F0"/>
@@ -3174,7 +3174,7 @@
                   </a:tcPr>
                 </a:tc>
               </a:tr>
-              <a:tr h="301752">
+              <a:tr h="274320">
                 <a:tc>
                   <a:txBody>
                     <a:bodyPr/>
@@ -3201,7 +3201,7 @@
                       </a:endParaRPr>
                     </a:p>
                   </a:txBody>
-                  <a:tcPr marL="91440" marR="91440" marT="0" marB="0" anchor="ctr">
+                  <a:tcPr marL="73152" marR="73152" marT="0" marB="0" anchor="ctr">
                     <a:lnL w="9525" cap="flat" cmpd="sng" algn="ctr">
                       <a:solidFill>
                         <a:srgbClr val="E2E8F0"/>
@@ -3269,7 +3269,7 @@
                       </a:endParaRPr>
                     </a:p>
                   </a:txBody>
-                  <a:tcPr marL="91440" marR="91440" marT="0" marB="0" anchor="ctr">
+                  <a:tcPr marL="73152" marR="73152" marT="0" marB="0" anchor="ctr">
                     <a:lnL w="9525" cap="flat" cmpd="sng" algn="ctr">
                       <a:solidFill>
                         <a:srgbClr val="E2E8F0"/>
@@ -3312,7 +3312,283 @@
                   </a:tcPr>
                 </a:tc>
               </a:tr>
-              <a:tr h="301752">
+              <a:tr h="274320">
+                <a:tc>
+                  <a:txBody>
+                    <a:bodyPr/>
+                    <a:lstStyle/>
+                    <a:p>
+                      <a:pPr indent="0" marL="0">
+                        <a:buNone/>
+                      </a:pPr>
+                      <a:r>
+                        <a:rPr lang="en-US" sz="1050" dirty="0">
+                          <a:solidFill>
+                            <a:srgbClr val="0F172A"/>
+                          </a:solidFill>
+                          <a:latin typeface="Calibri" pitchFamily="34" charset="0"/>
+                          <a:ea typeface="Calibri" pitchFamily="34" charset="-122"/>
+                          <a:cs typeface="Calibri" pitchFamily="34" charset="-120"/>
+                        </a:rPr>
+                        <a:t>Start a new notebook from Drive</a:t>
+                      </a:r>
+                      <a:endParaRPr lang="en-US" sz="1050" dirty="0">
+                        <a:latin typeface="Calibri" charset="0"/>
+                        <a:ea typeface="Calibri" charset="0"/>
+                        <a:cs typeface="Calibri" charset="0"/>
+                      </a:endParaRPr>
+                    </a:p>
+                  </a:txBody>
+                  <a:tcPr marL="73152" marR="73152" marT="0" marB="0" anchor="ctr">
+                    <a:lnL w="9525" cap="flat" cmpd="sng" algn="ctr">
+                      <a:solidFill>
+                        <a:srgbClr val="E2E8F0"/>
+                      </a:solidFill>
+                      <a:prstDash val="solid"/>
+                      <a:round/>
+                      <a:headEnd type="none" w="med" len="med"/>
+                      <a:tailEnd type="none" w="med" len="med"/>
+                    </a:lnL>
+                    <a:lnR w="9525" cap="flat" cmpd="sng" algn="ctr">
+                      <a:solidFill>
+                        <a:srgbClr val="E2E8F0"/>
+                      </a:solidFill>
+                      <a:prstDash val="solid"/>
+                      <a:round/>
+                      <a:headEnd type="none" w="med" len="med"/>
+                      <a:tailEnd type="none" w="med" len="med"/>
+                    </a:lnR>
+                    <a:lnT w="9525" cap="flat" cmpd="sng" algn="ctr">
+                      <a:solidFill>
+                        <a:srgbClr val="E2E8F0"/>
+                      </a:solidFill>
+                      <a:prstDash val="solid"/>
+                      <a:round/>
+                      <a:headEnd type="none" w="med" len="med"/>
+                      <a:tailEnd type="none" w="med" len="med"/>
+                    </a:lnT>
+                    <a:lnB w="9525" cap="flat" cmpd="sng" algn="ctr">
+                      <a:solidFill>
+                        <a:srgbClr val="E2E8F0"/>
+                      </a:solidFill>
+                      <a:prstDash val="solid"/>
+                      <a:round/>
+                      <a:headEnd type="none" w="med" len="med"/>
+                      <a:tailEnd type="none" w="med" len="med"/>
+                    </a:lnB>
+                    <a:solidFill>
+                      <a:srgbClr val="F8FAFC"/>
+                    </a:solidFill>
+                  </a:tcPr>
+                </a:tc>
+                <a:tc>
+                  <a:txBody>
+                    <a:bodyPr/>
+                    <a:lstStyle/>
+                    <a:p>
+                      <a:pPr indent="0" marL="0">
+                        <a:buNone/>
+                      </a:pPr>
+                      <a:r>
+                        <a:rPr lang="en-US" sz="1050" dirty="0">
+                          <a:solidFill>
+                            <a:srgbClr val="0F172A"/>
+                          </a:solidFill>
+                          <a:latin typeface="Calibri" pitchFamily="34" charset="0"/>
+                          <a:ea typeface="Calibri" pitchFamily="34" charset="-122"/>
+                          <a:cs typeface="Calibri" pitchFamily="34" charset="-120"/>
+                        </a:rPr>
+                        <a:t>Drive → New → More → Google Colaboratory</a:t>
+                      </a:r>
+                      <a:endParaRPr lang="en-US" sz="1050" dirty="0">
+                        <a:latin typeface="Calibri" charset="0"/>
+                        <a:ea typeface="Calibri" charset="0"/>
+                        <a:cs typeface="Calibri" charset="0"/>
+                      </a:endParaRPr>
+                    </a:p>
+                  </a:txBody>
+                  <a:tcPr marL="73152" marR="73152" marT="0" marB="0" anchor="ctr">
+                    <a:lnL w="9525" cap="flat" cmpd="sng" algn="ctr">
+                      <a:solidFill>
+                        <a:srgbClr val="E2E8F0"/>
+                      </a:solidFill>
+                      <a:prstDash val="solid"/>
+                      <a:round/>
+                      <a:headEnd type="none" w="med" len="med"/>
+                      <a:tailEnd type="none" w="med" len="med"/>
+                    </a:lnL>
+                    <a:lnR w="9525" cap="flat" cmpd="sng" algn="ctr">
+                      <a:solidFill>
+                        <a:srgbClr val="E2E8F0"/>
+                      </a:solidFill>
+                      <a:prstDash val="solid"/>
+                      <a:round/>
+                      <a:headEnd type="none" w="med" len="med"/>
+                      <a:tailEnd type="none" w="med" len="med"/>
+                    </a:lnR>
+                    <a:lnT w="9525" cap="flat" cmpd="sng" algn="ctr">
+                      <a:solidFill>
+                        <a:srgbClr val="E2E8F0"/>
+                      </a:solidFill>
+                      <a:prstDash val="solid"/>
+                      <a:round/>
+                      <a:headEnd type="none" w="med" len="med"/>
+                      <a:tailEnd type="none" w="med" len="med"/>
+                    </a:lnT>
+                    <a:lnB w="9525" cap="flat" cmpd="sng" algn="ctr">
+                      <a:solidFill>
+                        <a:srgbClr val="E2E8F0"/>
+                      </a:solidFill>
+                      <a:prstDash val="solid"/>
+                      <a:round/>
+                      <a:headEnd type="none" w="med" len="med"/>
+                      <a:tailEnd type="none" w="med" len="med"/>
+                    </a:lnB>
+                    <a:solidFill>
+                      <a:srgbClr val="F8FAFC"/>
+                    </a:solidFill>
+                  </a:tcPr>
+                </a:tc>
+              </a:tr>
+              <a:tr h="274320">
+                <a:tc>
+                  <a:txBody>
+                    <a:bodyPr/>
+                    <a:lstStyle/>
+                    <a:p>
+                      <a:pPr indent="0" marL="0">
+                        <a:buNone/>
+                      </a:pPr>
+                      <a:r>
+                        <a:rPr lang="en-US" sz="1050" dirty="0">
+                          <a:solidFill>
+                            <a:srgbClr val="0F172A"/>
+                          </a:solidFill>
+                          <a:latin typeface="Calibri" pitchFamily="34" charset="0"/>
+                          <a:ea typeface="Calibri" pitchFamily="34" charset="-122"/>
+                          <a:cs typeface="Calibri" pitchFamily="34" charset="-120"/>
+                        </a:rPr>
+                        <a:t>Open Colab directly</a:t>
+                      </a:r>
+                      <a:endParaRPr lang="en-US" sz="1050" dirty="0">
+                        <a:latin typeface="Calibri" charset="0"/>
+                        <a:ea typeface="Calibri" charset="0"/>
+                        <a:cs typeface="Calibri" charset="0"/>
+                      </a:endParaRPr>
+                    </a:p>
+                  </a:txBody>
+                  <a:tcPr marL="73152" marR="73152" marT="0" marB="0" anchor="ctr">
+                    <a:lnL w="9525" cap="flat" cmpd="sng" algn="ctr">
+                      <a:solidFill>
+                        <a:srgbClr val="E2E8F0"/>
+                      </a:solidFill>
+                      <a:prstDash val="solid"/>
+                      <a:round/>
+                      <a:headEnd type="none" w="med" len="med"/>
+                      <a:tailEnd type="none" w="med" len="med"/>
+                    </a:lnL>
+                    <a:lnR w="9525" cap="flat" cmpd="sng" algn="ctr">
+                      <a:solidFill>
+                        <a:srgbClr val="E2E8F0"/>
+                      </a:solidFill>
+                      <a:prstDash val="solid"/>
+                      <a:round/>
+                      <a:headEnd type="none" w="med" len="med"/>
+                      <a:tailEnd type="none" w="med" len="med"/>
+                    </a:lnR>
+                    <a:lnT w="9525" cap="flat" cmpd="sng" algn="ctr">
+                      <a:solidFill>
+                        <a:srgbClr val="E2E8F0"/>
+                      </a:solidFill>
+                      <a:prstDash val="solid"/>
+                      <a:round/>
+                      <a:headEnd type="none" w="med" len="med"/>
+                      <a:tailEnd type="none" w="med" len="med"/>
+                    </a:lnT>
+                    <a:lnB w="9525" cap="flat" cmpd="sng" algn="ctr">
+                      <a:solidFill>
+                        <a:srgbClr val="E2E8F0"/>
+                      </a:solidFill>
+                      <a:prstDash val="solid"/>
+                      <a:round/>
+                      <a:headEnd type="none" w="med" len="med"/>
+                      <a:tailEnd type="none" w="med" len="med"/>
+                    </a:lnB>
+                    <a:solidFill>
+                      <a:srgbClr val="FFFFFF"/>
+                    </a:solidFill>
+                  </a:tcPr>
+                </a:tc>
+                <a:tc>
+                  <a:txBody>
+                    <a:bodyPr/>
+                    <a:lstStyle/>
+                    <a:p>
+                      <a:pPr indent="0" marL="0">
+                        <a:buNone/>
+                      </a:pPr>
+                      <a:r>
+                        <a:rPr lang="en-US" sz="1050" dirty="0">
+                          <a:solidFill>
+                            <a:srgbClr val="0F172A"/>
+                          </a:solidFill>
+                          <a:latin typeface="Calibri" pitchFamily="34" charset="0"/>
+                          <a:ea typeface="Calibri" pitchFamily="34" charset="-122"/>
+                          <a:cs typeface="Calibri" pitchFamily="34" charset="-120"/>
+                        </a:rPr>
+                        <a:t>colab.research.google.com → File → Upload notebook</a:t>
+                      </a:r>
+                      <a:endParaRPr lang="en-US" sz="1050" dirty="0">
+                        <a:latin typeface="Calibri" charset="0"/>
+                        <a:ea typeface="Calibri" charset="0"/>
+                        <a:cs typeface="Calibri" charset="0"/>
+                      </a:endParaRPr>
+                    </a:p>
+                  </a:txBody>
+                  <a:tcPr marL="73152" marR="73152" marT="0" marB="0" anchor="ctr">
+                    <a:lnL w="9525" cap="flat" cmpd="sng" algn="ctr">
+                      <a:solidFill>
+                        <a:srgbClr val="E2E8F0"/>
+                      </a:solidFill>
+                      <a:prstDash val="solid"/>
+                      <a:round/>
+                      <a:headEnd type="none" w="med" len="med"/>
+                      <a:tailEnd type="none" w="med" len="med"/>
+                    </a:lnL>
+                    <a:lnR w="9525" cap="flat" cmpd="sng" algn="ctr">
+                      <a:solidFill>
+                        <a:srgbClr val="E2E8F0"/>
+                      </a:solidFill>
+                      <a:prstDash val="solid"/>
+                      <a:round/>
+                      <a:headEnd type="none" w="med" len="med"/>
+                      <a:tailEnd type="none" w="med" len="med"/>
+                    </a:lnR>
+                    <a:lnT w="9525" cap="flat" cmpd="sng" algn="ctr">
+                      <a:solidFill>
+                        <a:srgbClr val="E2E8F0"/>
+                      </a:solidFill>
+                      <a:prstDash val="solid"/>
+                      <a:round/>
+                      <a:headEnd type="none" w="med" len="med"/>
+                      <a:tailEnd type="none" w="med" len="med"/>
+                    </a:lnT>
+                    <a:lnB w="9525" cap="flat" cmpd="sng" algn="ctr">
+                      <a:solidFill>
+                        <a:srgbClr val="E2E8F0"/>
+                      </a:solidFill>
+                      <a:prstDash val="solid"/>
+                      <a:round/>
+                      <a:headEnd type="none" w="med" len="med"/>
+                      <a:tailEnd type="none" w="med" len="med"/>
+                    </a:lnB>
+                    <a:solidFill>
+                      <a:srgbClr val="FFFFFF"/>
+                    </a:solidFill>
+                  </a:tcPr>
+                </a:tc>
+              </a:tr>
+              <a:tr h="274320">
                 <a:tc>
                   <a:txBody>
                     <a:bodyPr/>
@@ -3339,7 +3615,7 @@
                       </a:endParaRPr>
                     </a:p>
                   </a:txBody>
-                  <a:tcPr marL="91440" marR="91440" marT="0" marB="0" anchor="ctr">
+                  <a:tcPr marL="73152" marR="73152" marT="0" marB="0" anchor="ctr">
                     <a:lnL w="9525" cap="flat" cmpd="sng" algn="ctr">
                       <a:solidFill>
                         <a:srgbClr val="E2E8F0"/>
@@ -3407,7 +3683,7 @@
                       </a:endParaRPr>
                     </a:p>
                   </a:txBody>
-                  <a:tcPr marL="91440" marR="91440" marT="0" marB="0" anchor="ctr">
+                  <a:tcPr marL="73152" marR="73152" marT="0" marB="0" anchor="ctr">
                     <a:lnL w="9525" cap="flat" cmpd="sng" algn="ctr">
                       <a:solidFill>
                         <a:srgbClr val="E2E8F0"/>
@@ -3450,7 +3726,7 @@
                   </a:tcPr>
                 </a:tc>
               </a:tr>
-              <a:tr h="301752">
+              <a:tr h="274320">
                 <a:tc>
                   <a:txBody>
                     <a:bodyPr/>
@@ -3477,7 +3753,7 @@
                       </a:endParaRPr>
                     </a:p>
                   </a:txBody>
-                  <a:tcPr marL="91440" marR="91440" marT="0" marB="0" anchor="ctr">
+                  <a:tcPr marL="73152" marR="73152" marT="0" marB="0" anchor="ctr">
                     <a:lnL w="9525" cap="flat" cmpd="sng" algn="ctr">
                       <a:solidFill>
                         <a:srgbClr val="E2E8F0"/>
@@ -3545,7 +3821,7 @@
                       </a:endParaRPr>
                     </a:p>
                   </a:txBody>
-                  <a:tcPr marL="91440" marR="91440" marT="0" marB="0" anchor="ctr">
+                  <a:tcPr marL="73152" marR="73152" marT="0" marB="0" anchor="ctr">
                     <a:lnL w="9525" cap="flat" cmpd="sng" algn="ctr">
                       <a:solidFill>
                         <a:srgbClr val="E2E8F0"/>
@@ -3588,7 +3864,7 @@
                   </a:tcPr>
                 </a:tc>
               </a:tr>
-              <a:tr h="301752">
+              <a:tr h="274320">
                 <a:tc>
                   <a:txBody>
                     <a:bodyPr/>
@@ -3615,7 +3891,7 @@
                       </a:endParaRPr>
                     </a:p>
                   </a:txBody>
-                  <a:tcPr marL="91440" marR="91440" marT="0" marB="0" anchor="ctr">
+                  <a:tcPr marL="73152" marR="73152" marT="0" marB="0" anchor="ctr">
                     <a:lnL w="9525" cap="flat" cmpd="sng" algn="ctr">
                       <a:solidFill>
                         <a:srgbClr val="E2E8F0"/>
@@ -3683,7 +3959,7 @@
                       </a:endParaRPr>
                     </a:p>
                   </a:txBody>
-                  <a:tcPr marL="91440" marR="91440" marT="0" marB="0" anchor="ctr">
+                  <a:tcPr marL="73152" marR="73152" marT="0" marB="0" anchor="ctr">
                     <a:lnL w="9525" cap="flat" cmpd="sng" algn="ctr">
                       <a:solidFill>
                         <a:srgbClr val="E2E8F0"/>
@@ -3726,7 +4002,7 @@
                   </a:tcPr>
                 </a:tc>
               </a:tr>
-              <a:tr h="301752">
+              <a:tr h="274320">
                 <a:tc>
                   <a:txBody>
                     <a:bodyPr/>
@@ -3753,7 +4029,7 @@
                       </a:endParaRPr>
                     </a:p>
                   </a:txBody>
-                  <a:tcPr marL="91440" marR="91440" marT="0" marB="0" anchor="ctr">
+                  <a:tcPr marL="73152" marR="73152" marT="0" marB="0" anchor="ctr">
                     <a:lnL w="9525" cap="flat" cmpd="sng" algn="ctr">
                       <a:solidFill>
                         <a:srgbClr val="E2E8F0"/>
@@ -3821,7 +4097,7 @@
                       </a:endParaRPr>
                     </a:p>
                   </a:txBody>
-                  <a:tcPr marL="91440" marR="91440" marT="0" marB="0" anchor="ctr">
+                  <a:tcPr marL="73152" marR="73152" marT="0" marB="0" anchor="ctr">
                     <a:lnL w="9525" cap="flat" cmpd="sng" algn="ctr">
                       <a:solidFill>
                         <a:srgbClr val="E2E8F0"/>
@@ -3864,7 +4140,7 @@
                   </a:tcPr>
                 </a:tc>
               </a:tr>
-              <a:tr h="301752">
+              <a:tr h="274320">
                 <a:tc>
                   <a:txBody>
                     <a:bodyPr/>
@@ -3891,7 +4167,7 @@
                       </a:endParaRPr>
                     </a:p>
                   </a:txBody>
-                  <a:tcPr marL="91440" marR="91440" marT="0" marB="0" anchor="ctr">
+                  <a:tcPr marL="73152" marR="73152" marT="0" marB="0" anchor="ctr">
                     <a:lnL w="9525" cap="flat" cmpd="sng" algn="ctr">
                       <a:solidFill>
                         <a:srgbClr val="E2E8F0"/>
@@ -3959,7 +4235,7 @@
                       </a:endParaRPr>
                     </a:p>
                   </a:txBody>
-                  <a:tcPr marL="91440" marR="91440" marT="0" marB="0" anchor="ctr">
+                  <a:tcPr marL="73152" marR="73152" marT="0" marB="0" anchor="ctr">
                     <a:lnL w="9525" cap="flat" cmpd="sng" algn="ctr">
                       <a:solidFill>
                         <a:srgbClr val="E2E8F0"/>
@@ -4014,7 +4290,7 @@
         </p:nvSpPr>
         <p:spPr>
           <a:xfrm>
-            <a:off x="457200" y="4315968"/>
+            <a:off x="457200" y="4434840"/>
             <a:ext cx="8229600" cy="457200"/>
           </a:xfrm>
           <a:prstGeom prst="rect">

</xml_diff>